<commit_message>
Refactor create_split_bullet_slide function to improve section layout and content handling. Update presentation_agent to set max_turns parameter for event streaming. Update test presentation file.
</commit_message>
<xml_diff>
--- a/src/tests/test_split_bullet_slide.pptx
+++ b/src/tests/test_split_bullet_slide.pptx
@@ -3168,122 +3168,6 @@
         </p:nvSpPr>
         <p:spPr>
           <a:xfrm>
-            <a:off x="5303520" y="640080"/>
-            <a:ext cx="3383280" cy="6350"/>
-          </a:xfrm>
-          <a:prstGeom prst="rect">
-            <a:avLst/>
-          </a:prstGeom>
-          <a:solidFill>
-            <a:srgbClr val="C8C8C8"/>
-          </a:solidFill>
-          <a:ln>
-            <a:noFill/>
-          </a:ln>
-          <a:effectLst/>
-        </p:spPr>
-        <p:style>
-          <a:lnRef idx="1">
-            <a:schemeClr val="accent1"/>
-          </a:lnRef>
-          <a:fillRef idx="3">
-            <a:schemeClr val="accent1"/>
-          </a:fillRef>
-          <a:effectRef idx="2">
-            <a:schemeClr val="accent1"/>
-          </a:effectRef>
-          <a:fontRef idx="minor">
-            <a:schemeClr val="lt1"/>
-          </a:fontRef>
-        </p:style>
-        <p:txBody>
-          <a:bodyPr rtlCol="0" anchor="ctr"/>
-          <a:lstStyle/>
-          <a:p>
-            <a:pPr algn="ctr"/>
-          </a:p>
-        </p:txBody>
-      </p:sp>
-      <p:sp>
-        <p:nvSpPr>
-          <p:cNvPr id="5" name="TextBox 4"/>
-          <p:cNvSpPr txBox="1"/>
-          <p:nvPr/>
-        </p:nvSpPr>
-        <p:spPr>
-          <a:xfrm>
-            <a:off x="5303520" y="741680"/>
-            <a:ext cx="3383280" cy="365760"/>
-          </a:xfrm>
-          <a:prstGeom prst="rect">
-            <a:avLst/>
-          </a:prstGeom>
-          <a:noFill/>
-        </p:spPr>
-        <p:txBody>
-          <a:bodyPr wrap="square">
-            <a:spAutoFit/>
-          </a:bodyPr>
-          <a:lstStyle/>
-          <a:p>
-            <a:pPr algn="l">
-              <a:defRPr sz="1500" b="1">
-                <a:solidFill>
-                  <a:srgbClr val="333333"/>
-                </a:solidFill>
-                <a:latin typeface="Albert Sans"/>
-              </a:defRPr>
-            </a:pPr>
-            <a:r>
-              <a:t>Premium Hardware Cadence</a:t>
-            </a:r>
-          </a:p>
-        </p:txBody>
-      </p:sp>
-      <p:sp>
-        <p:nvSpPr>
-          <p:cNvPr id="6" name="TextBox 5"/>
-          <p:cNvSpPr txBox="1"/>
-          <p:nvPr/>
-        </p:nvSpPr>
-        <p:spPr>
-          <a:xfrm>
-            <a:off x="5303520" y="1107440"/>
-            <a:ext cx="3383280" cy="546608"/>
-          </a:xfrm>
-          <a:prstGeom prst="rect">
-            <a:avLst/>
-          </a:prstGeom>
-          <a:noFill/>
-        </p:spPr>
-        <p:txBody>
-          <a:bodyPr wrap="square">
-            <a:spAutoFit/>
-          </a:bodyPr>
-          <a:lstStyle/>
-          <a:p>
-            <a:pPr algn="l">
-              <a:defRPr sz="1100">
-                <a:solidFill>
-                  <a:srgbClr val="8E8E8E"/>
-                </a:solidFill>
-                <a:latin typeface="Albert Sans"/>
-              </a:defRPr>
-            </a:pPr>
-            <a:r>
-              <a:t>New launches for iPhone Pro, Mac, iPad, and Vision Pro to sustain market leadership.</a:t>
-            </a:r>
-          </a:p>
-        </p:txBody>
-      </p:sp>
-      <p:sp>
-        <p:nvSpPr>
-          <p:cNvPr id="7" name="Rectangle 6"/>
-          <p:cNvSpPr/>
-          <p:nvPr/>
-        </p:nvSpPr>
-        <p:spPr>
-          <a:xfrm>
             <a:off x="5303520" y="1755648"/>
             <a:ext cx="3383280" cy="6350"/>
           </a:xfrm>
@@ -3322,79 +3206,7 @@
       </p:sp>
       <p:sp>
         <p:nvSpPr>
-          <p:cNvPr id="8" name="TextBox 7"/>
-          <p:cNvSpPr txBox="1"/>
-          <p:nvPr/>
-        </p:nvSpPr>
-        <p:spPr>
-          <a:xfrm>
-            <a:off x="5303520" y="1857248"/>
-            <a:ext cx="3383280" cy="365760"/>
-          </a:xfrm>
-          <a:prstGeom prst="rect">
-            <a:avLst/>
-          </a:prstGeom>
-          <a:noFill/>
-        </p:spPr>
-        <p:txBody>
-          <a:bodyPr wrap="square">
-            <a:spAutoFit/>
-          </a:bodyPr>
-          <a:lstStyle/>
-          <a:p>
-            <a:pPr algn="l">
-              <a:defRPr sz="1500" b="1">
-                <a:solidFill>
-                  <a:srgbClr val="333333"/>
-                </a:solidFill>
-                <a:latin typeface="Albert Sans"/>
-              </a:defRPr>
-            </a:pPr>
-            <a:r>
-              <a:t>Services Expansion</a:t>
-            </a:r>
-          </a:p>
-        </p:txBody>
-      </p:sp>
-      <p:sp>
-        <p:nvSpPr>
-          <p:cNvPr id="9" name="TextBox 8"/>
-          <p:cNvSpPr txBox="1"/>
-          <p:nvPr/>
-        </p:nvSpPr>
-        <p:spPr>
-          <a:xfrm>
-            <a:off x="5303520" y="2223008"/>
-            <a:ext cx="3383280" cy="546608"/>
-          </a:xfrm>
-          <a:prstGeom prst="rect">
-            <a:avLst/>
-          </a:prstGeom>
-          <a:noFill/>
-        </p:spPr>
-        <p:txBody>
-          <a:bodyPr wrap="square">
-            <a:spAutoFit/>
-          </a:bodyPr>
-          <a:lstStyle/>
-          <a:p>
-            <a:pPr algn="l">
-              <a:defRPr sz="1100">
-                <a:solidFill>
-                  <a:srgbClr val="8E8E8E"/>
-                </a:solidFill>
-                <a:latin typeface="Albert Sans"/>
-              </a:defRPr>
-            </a:pPr>
-            <a:r>
-              <a:t>Growth in advertising, App Store, cloud, Apple Pay, and AppleCare revenue streams.</a:t>
-            </a:r>
-          </a:p>
-        </p:txBody>
-      </p:sp>
-      <p:sp>
-        <p:nvSpPr>
-          <p:cNvPr id="10" name="Rectangle 9"/>
+          <p:cNvPr id="5" name="Rectangle 4"/>
           <p:cNvSpPr/>
           <p:nvPr/>
         </p:nvSpPr>
@@ -3438,79 +3250,7 @@
       </p:sp>
       <p:sp>
         <p:nvSpPr>
-          <p:cNvPr id="11" name="TextBox 10"/>
-          <p:cNvSpPr txBox="1"/>
-          <p:nvPr/>
-        </p:nvSpPr>
-        <p:spPr>
-          <a:xfrm>
-            <a:off x="5303520" y="2972816"/>
-            <a:ext cx="3383280" cy="365760"/>
-          </a:xfrm>
-          <a:prstGeom prst="rect">
-            <a:avLst/>
-          </a:prstGeom>
-          <a:noFill/>
-        </p:spPr>
-        <p:txBody>
-          <a:bodyPr wrap="square">
-            <a:spAutoFit/>
-          </a:bodyPr>
-          <a:lstStyle/>
-          <a:p>
-            <a:pPr algn="l">
-              <a:defRPr sz="1500" b="1">
-                <a:solidFill>
-                  <a:srgbClr val="333333"/>
-                </a:solidFill>
-                <a:latin typeface="Albert Sans"/>
-              </a:defRPr>
-            </a:pPr>
-            <a:r>
-              <a:t>R&amp;D Investment</a:t>
-            </a:r>
-          </a:p>
-        </p:txBody>
-      </p:sp>
-      <p:sp>
-        <p:nvSpPr>
-          <p:cNvPr id="12" name="TextBox 11"/>
-          <p:cNvSpPr txBox="1"/>
-          <p:nvPr/>
-        </p:nvSpPr>
-        <p:spPr>
-          <a:xfrm>
-            <a:off x="5303520" y="3338576"/>
-            <a:ext cx="3383280" cy="546608"/>
-          </a:xfrm>
-          <a:prstGeom prst="rect">
-            <a:avLst/>
-          </a:prstGeom>
-          <a:noFill/>
-        </p:spPr>
-        <p:txBody>
-          <a:bodyPr wrap="square">
-            <a:spAutoFit/>
-          </a:bodyPr>
-          <a:lstStyle/>
-          <a:p>
-            <a:pPr algn="l">
-              <a:defRPr sz="1100">
-                <a:solidFill>
-                  <a:srgbClr val="8E8E8E"/>
-                </a:solidFill>
-                <a:latin typeface="Albert Sans"/>
-              </a:defRPr>
-            </a:pPr>
-            <a:r>
-              <a:t>10% YoY increase ($34.6B) targeting AI, on-device intelligence, and spatial computing.</a:t>
-            </a:r>
-          </a:p>
-        </p:txBody>
-      </p:sp>
-      <p:sp>
-        <p:nvSpPr>
-          <p:cNvPr id="13" name="Rectangle 12"/>
+          <p:cNvPr id="6" name="Rectangle 5"/>
           <p:cNvSpPr/>
           <p:nvPr/>
         </p:nvSpPr>
@@ -3554,79 +3294,7 @@
       </p:sp>
       <p:sp>
         <p:nvSpPr>
-          <p:cNvPr id="14" name="TextBox 13"/>
-          <p:cNvSpPr txBox="1"/>
-          <p:nvPr/>
-        </p:nvSpPr>
-        <p:spPr>
-          <a:xfrm>
-            <a:off x="5303520" y="4088384"/>
-            <a:ext cx="3383280" cy="365760"/>
-          </a:xfrm>
-          <a:prstGeom prst="rect">
-            <a:avLst/>
-          </a:prstGeom>
-          <a:noFill/>
-        </p:spPr>
-        <p:txBody>
-          <a:bodyPr wrap="square">
-            <a:spAutoFit/>
-          </a:bodyPr>
-          <a:lstStyle/>
-          <a:p>
-            <a:pPr algn="l">
-              <a:defRPr sz="1500" b="1">
-                <a:solidFill>
-                  <a:srgbClr val="333333"/>
-                </a:solidFill>
-                <a:latin typeface="Albert Sans"/>
-              </a:defRPr>
-            </a:pPr>
-            <a:r>
-              <a:t>Supply Chain Resilience</a:t>
-            </a:r>
-          </a:p>
-        </p:txBody>
-      </p:sp>
-      <p:sp>
-        <p:nvSpPr>
-          <p:cNvPr id="15" name="TextBox 14"/>
-          <p:cNvSpPr txBox="1"/>
-          <p:nvPr/>
-        </p:nvSpPr>
-        <p:spPr>
-          <a:xfrm>
-            <a:off x="5303520" y="4454144"/>
-            <a:ext cx="3383280" cy="546608"/>
-          </a:xfrm>
-          <a:prstGeom prst="rect">
-            <a:avLst/>
-          </a:prstGeom>
-          <a:noFill/>
-        </p:spPr>
-        <p:txBody>
-          <a:bodyPr wrap="square">
-            <a:spAutoFit/>
-          </a:bodyPr>
-          <a:lstStyle/>
-          <a:p>
-            <a:pPr algn="l">
-              <a:defRPr sz="1100">
-                <a:solidFill>
-                  <a:srgbClr val="8E8E8E"/>
-                </a:solidFill>
-                <a:latin typeface="Albert Sans"/>
-              </a:defRPr>
-            </a:pPr>
-            <a:r>
-              <a:t>Navigating tariffs and geopolitical risks to ensure stability in production and distribution.</a:t>
-            </a:r>
-          </a:p>
-        </p:txBody>
-      </p:sp>
-      <p:sp>
-        <p:nvSpPr>
-          <p:cNvPr id="16" name="Rectangle 15"/>
+          <p:cNvPr id="7" name="Rectangle 6"/>
           <p:cNvSpPr/>
           <p:nvPr/>
         </p:nvSpPr>
@@ -3670,14 +3338,14 @@
       </p:sp>
       <p:sp>
         <p:nvSpPr>
-          <p:cNvPr id="17" name="TextBox 16"/>
+          <p:cNvPr id="8" name="TextBox 7"/>
           <p:cNvSpPr txBox="1"/>
           <p:nvPr/>
         </p:nvSpPr>
         <p:spPr>
           <a:xfrm>
-            <a:off x="5303520" y="5203952"/>
-            <a:ext cx="3383280" cy="365760"/>
+            <a:off x="5303520" y="640080"/>
+            <a:ext cx="3383280" cy="1115568"/>
           </a:xfrm>
           <a:prstGeom prst="rect">
             <a:avLst/>
@@ -3685,7 +3353,7 @@
           <a:noFill/>
         </p:spPr>
         <p:txBody>
-          <a:bodyPr wrap="square">
+          <a:bodyPr wrap="square" anchor="ctr" tIns="73152" bIns="73152">
             <a:spAutoFit/>
           </a:bodyPr>
           <a:lstStyle/>
@@ -3699,34 +3367,14 @@
               </a:defRPr>
             </a:pPr>
             <a:r>
-              <a:t>Geographic Expansion</a:t>
-            </a:r>
-          </a:p>
-        </p:txBody>
-      </p:sp>
-      <p:sp>
-        <p:nvSpPr>
-          <p:cNvPr id="18" name="TextBox 17"/>
-          <p:cNvSpPr txBox="1"/>
-          <p:nvPr/>
-        </p:nvSpPr>
-        <p:spPr>
-          <a:xfrm>
-            <a:off x="5303520" y="5569712"/>
-            <a:ext cx="3383280" cy="546608"/>
-          </a:xfrm>
-          <a:prstGeom prst="rect">
-            <a:avLst/>
-          </a:prstGeom>
-          <a:noFill/>
-        </p:spPr>
-        <p:txBody>
-          <a:bodyPr wrap="square">
-            <a:spAutoFit/>
-          </a:bodyPr>
-          <a:lstStyle/>
+              <a:t>Premium Hardware Cadence</a:t>
+            </a:r>
+          </a:p>
           <a:p>
             <a:pPr algn="l">
+              <a:spcBef>
+                <a:spcPts val="400"/>
+              </a:spcBef>
               <a:defRPr sz="1100">
                 <a:solidFill>
                   <a:srgbClr val="8E8E8E"/>
@@ -3735,52 +3383,216 @@
               </a:defRPr>
             </a:pPr>
             <a:r>
-              <a:t>Focusing on Europe and Japan while addressing demand fluctuations in China.</a:t>
-            </a:r>
-          </a:p>
-        </p:txBody>
-      </p:sp>
-      <p:sp>
-        <p:nvSpPr>
-          <p:cNvPr id="19" name="Rectangle 18"/>
-          <p:cNvSpPr/>
+              <a:t>New launches for iPhone Pro, Mac, iPad, and Vision Pro to sustain market leadership.</a:t>
+            </a:r>
+          </a:p>
+        </p:txBody>
+      </p:sp>
+      <p:sp>
+        <p:nvSpPr>
+          <p:cNvPr id="9" name="TextBox 8"/>
+          <p:cNvSpPr txBox="1"/>
           <p:nvPr/>
         </p:nvSpPr>
         <p:spPr>
           <a:xfrm>
-            <a:off x="5303520" y="6217920"/>
-            <a:ext cx="3383280" cy="6350"/>
+            <a:off x="5303520" y="1755648"/>
+            <a:ext cx="3383280" cy="1115568"/>
           </a:xfrm>
           <a:prstGeom prst="rect">
             <a:avLst/>
           </a:prstGeom>
-          <a:solidFill>
-            <a:srgbClr val="C8C8C8"/>
-          </a:solidFill>
-          <a:ln>
-            <a:noFill/>
-          </a:ln>
-          <a:effectLst/>
+          <a:noFill/>
         </p:spPr>
-        <p:style>
-          <a:lnRef idx="1">
-            <a:schemeClr val="accent1"/>
-          </a:lnRef>
-          <a:fillRef idx="3">
-            <a:schemeClr val="accent1"/>
-          </a:fillRef>
-          <a:effectRef idx="2">
-            <a:schemeClr val="accent1"/>
-          </a:effectRef>
-          <a:fontRef idx="minor">
-            <a:schemeClr val="lt1"/>
-          </a:fontRef>
-        </p:style>
-        <p:txBody>
-          <a:bodyPr rtlCol="0" anchor="ctr"/>
-          <a:lstStyle/>
-          <a:p>
-            <a:pPr algn="ctr"/>
+        <p:txBody>
+          <a:bodyPr wrap="square" anchor="ctr" tIns="73152" bIns="73152">
+            <a:spAutoFit/>
+          </a:bodyPr>
+          <a:lstStyle/>
+          <a:p>
+            <a:pPr algn="l">
+              <a:defRPr sz="1500" b="1">
+                <a:solidFill>
+                  <a:srgbClr val="333333"/>
+                </a:solidFill>
+                <a:latin typeface="Albert Sans"/>
+              </a:defRPr>
+            </a:pPr>
+            <a:r>
+              <a:t>Services Expansion</a:t>
+            </a:r>
+          </a:p>
+          <a:p>
+            <a:pPr algn="l">
+              <a:spcBef>
+                <a:spcPts val="400"/>
+              </a:spcBef>
+              <a:defRPr sz="1100">
+                <a:solidFill>
+                  <a:srgbClr val="8E8E8E"/>
+                </a:solidFill>
+                <a:latin typeface="Albert Sans"/>
+              </a:defRPr>
+            </a:pPr>
+            <a:r>
+              <a:t>Growth in advertising, App Store, cloud, Apple Pay, and AppleCare revenue streams.</a:t>
+            </a:r>
+          </a:p>
+        </p:txBody>
+      </p:sp>
+      <p:sp>
+        <p:nvSpPr>
+          <p:cNvPr id="10" name="TextBox 9"/>
+          <p:cNvSpPr txBox="1"/>
+          <p:nvPr/>
+        </p:nvSpPr>
+        <p:spPr>
+          <a:xfrm>
+            <a:off x="5303520" y="2871216"/>
+            <a:ext cx="3383280" cy="1115568"/>
+          </a:xfrm>
+          <a:prstGeom prst="rect">
+            <a:avLst/>
+          </a:prstGeom>
+          <a:noFill/>
+        </p:spPr>
+        <p:txBody>
+          <a:bodyPr wrap="square" anchor="ctr" tIns="73152" bIns="73152">
+            <a:spAutoFit/>
+          </a:bodyPr>
+          <a:lstStyle/>
+          <a:p>
+            <a:pPr algn="l">
+              <a:defRPr sz="1500" b="1">
+                <a:solidFill>
+                  <a:srgbClr val="333333"/>
+                </a:solidFill>
+                <a:latin typeface="Albert Sans"/>
+              </a:defRPr>
+            </a:pPr>
+            <a:r>
+              <a:t>R&amp;D Investment</a:t>
+            </a:r>
+          </a:p>
+          <a:p>
+            <a:pPr algn="l">
+              <a:spcBef>
+                <a:spcPts val="400"/>
+              </a:spcBef>
+              <a:defRPr sz="1100">
+                <a:solidFill>
+                  <a:srgbClr val="8E8E8E"/>
+                </a:solidFill>
+                <a:latin typeface="Albert Sans"/>
+              </a:defRPr>
+            </a:pPr>
+            <a:r>
+              <a:t>10% YoY increase ($34.6B) targeting AI, on-device intelligence, and spatial computing.</a:t>
+            </a:r>
+          </a:p>
+        </p:txBody>
+      </p:sp>
+      <p:sp>
+        <p:nvSpPr>
+          <p:cNvPr id="11" name="TextBox 10"/>
+          <p:cNvSpPr txBox="1"/>
+          <p:nvPr/>
+        </p:nvSpPr>
+        <p:spPr>
+          <a:xfrm>
+            <a:off x="5303520" y="3986784"/>
+            <a:ext cx="3383280" cy="1115568"/>
+          </a:xfrm>
+          <a:prstGeom prst="rect">
+            <a:avLst/>
+          </a:prstGeom>
+          <a:noFill/>
+        </p:spPr>
+        <p:txBody>
+          <a:bodyPr wrap="square" anchor="ctr" tIns="73152" bIns="73152">
+            <a:spAutoFit/>
+          </a:bodyPr>
+          <a:lstStyle/>
+          <a:p>
+            <a:pPr algn="l">
+              <a:defRPr sz="1500" b="1">
+                <a:solidFill>
+                  <a:srgbClr val="333333"/>
+                </a:solidFill>
+                <a:latin typeface="Albert Sans"/>
+              </a:defRPr>
+            </a:pPr>
+            <a:r>
+              <a:t>Supply Chain Resilience</a:t>
+            </a:r>
+          </a:p>
+          <a:p>
+            <a:pPr algn="l">
+              <a:spcBef>
+                <a:spcPts val="400"/>
+              </a:spcBef>
+              <a:defRPr sz="1100">
+                <a:solidFill>
+                  <a:srgbClr val="8E8E8E"/>
+                </a:solidFill>
+                <a:latin typeface="Albert Sans"/>
+              </a:defRPr>
+            </a:pPr>
+            <a:r>
+              <a:t>Navigating tariffs and geopolitical risks to ensure stability in production and distribution.</a:t>
+            </a:r>
+          </a:p>
+        </p:txBody>
+      </p:sp>
+      <p:sp>
+        <p:nvSpPr>
+          <p:cNvPr id="12" name="TextBox 11"/>
+          <p:cNvSpPr txBox="1"/>
+          <p:nvPr/>
+        </p:nvSpPr>
+        <p:spPr>
+          <a:xfrm>
+            <a:off x="5303520" y="5102352"/>
+            <a:ext cx="3383280" cy="1115568"/>
+          </a:xfrm>
+          <a:prstGeom prst="rect">
+            <a:avLst/>
+          </a:prstGeom>
+          <a:noFill/>
+        </p:spPr>
+        <p:txBody>
+          <a:bodyPr wrap="square" anchor="ctr" tIns="73152" bIns="73152">
+            <a:spAutoFit/>
+          </a:bodyPr>
+          <a:lstStyle/>
+          <a:p>
+            <a:pPr algn="l">
+              <a:defRPr sz="1500" b="1">
+                <a:solidFill>
+                  <a:srgbClr val="333333"/>
+                </a:solidFill>
+                <a:latin typeface="Albert Sans"/>
+              </a:defRPr>
+            </a:pPr>
+            <a:r>
+              <a:t>Geographic Expansion</a:t>
+            </a:r>
+          </a:p>
+          <a:p>
+            <a:pPr algn="l">
+              <a:spcBef>
+                <a:spcPts val="400"/>
+              </a:spcBef>
+              <a:defRPr sz="1100">
+                <a:solidFill>
+                  <a:srgbClr val="8E8E8E"/>
+                </a:solidFill>
+                <a:latin typeface="Albert Sans"/>
+              </a:defRPr>
+            </a:pPr>
+            <a:r>
+              <a:t>Focusing on Europe and Japan while addressing demand fluctuations in China.</a:t>
+            </a:r>
           </a:p>
         </p:txBody>
       </p:sp>

</xml_diff>